<commit_message>
merged input from Alex
</commit_message>
<xml_diff>
--- a/125/NMOP/draft-ietf-nmop-yang-message-broker-message-key-01.pptx
+++ b/125/NMOP/draft-ietf-nmop-yang-message-broker-message-key-01.pptx
@@ -9,8 +9,8 @@
   </p:notesMasterIdLst>
   <p:sldIdLst>
     <p:sldId id="1041" r:id="rId2"/>
-    <p:sldId id="2145706305" r:id="rId3"/>
-    <p:sldId id="2145706298" r:id="rId4"/>
+    <p:sldId id="2145706298" r:id="rId3"/>
+    <p:sldId id="2145706305" r:id="rId4"/>
     <p:sldId id="2145706304" r:id="rId5"/>
     <p:sldId id="2145706306" r:id="rId6"/>
     <p:sldId id="2145706220" r:id="rId7"/>
@@ -599,12 +599,12 @@
   <pc:docChgLst>
     <pc:chgData name="Graf Thomas, SCS-INI-NET-VNC-E2E" userId="487bc3e3-9ce7-4cdd-b7b4-8899ea88d289" providerId="ADAL" clId="{ADEEF08A-D719-4B50-A383-4105EDA2C206}"/>
     <pc:docChg chg="undo custSel delSld modSld sldOrd">
-      <pc:chgData name="Graf Thomas, SCS-INI-NET-VNC-E2E" userId="487bc3e3-9ce7-4cdd-b7b4-8899ea88d289" providerId="ADAL" clId="{ADEEF08A-D719-4B50-A383-4105EDA2C206}" dt="2026-03-06T14:10:47.728" v="1722" actId="20577"/>
+      <pc:chgData name="Graf Thomas, SCS-INI-NET-VNC-E2E" userId="487bc3e3-9ce7-4cdd-b7b4-8899ea88d289" providerId="ADAL" clId="{ADEEF08A-D719-4B50-A383-4105EDA2C206}" dt="2026-03-14T09:27:50.013" v="1735"/>
       <pc:docMkLst>
         <pc:docMk/>
       </pc:docMkLst>
       <pc:sldChg chg="modSp mod">
-        <pc:chgData name="Graf Thomas, SCS-INI-NET-VNC-E2E" userId="487bc3e3-9ce7-4cdd-b7b4-8899ea88d289" providerId="ADAL" clId="{ADEEF08A-D719-4B50-A383-4105EDA2C206}" dt="2026-03-06T14:10:44.146" v="1721" actId="20577"/>
+        <pc:chgData name="Graf Thomas, SCS-INI-NET-VNC-E2E" userId="487bc3e3-9ce7-4cdd-b7b4-8899ea88d289" providerId="ADAL" clId="{ADEEF08A-D719-4B50-A383-4105EDA2C206}" dt="2026-03-14T09:24:32.967" v="1725" actId="20577"/>
         <pc:sldMkLst>
           <pc:docMk/>
           <pc:sldMk cId="3578665336" sldId="1041"/>
@@ -618,7 +618,7 @@
           </ac:spMkLst>
         </pc:spChg>
         <pc:spChg chg="mod">
-          <ac:chgData name="Graf Thomas, SCS-INI-NET-VNC-E2E" userId="487bc3e3-9ce7-4cdd-b7b4-8899ea88d289" providerId="ADAL" clId="{ADEEF08A-D719-4B50-A383-4105EDA2C206}" dt="2026-03-06T14:10:44.146" v="1721" actId="20577"/>
+          <ac:chgData name="Graf Thomas, SCS-INI-NET-VNC-E2E" userId="487bc3e3-9ce7-4cdd-b7b4-8899ea88d289" providerId="ADAL" clId="{ADEEF08A-D719-4B50-A383-4105EDA2C206}" dt="2026-03-14T09:24:32.967" v="1725" actId="20577"/>
           <ac:spMkLst>
             <pc:docMk/>
             <pc:sldMk cId="3578665336" sldId="1041"/>
@@ -662,7 +662,7 @@
         </pc:sldMkLst>
       </pc:sldChg>
       <pc:sldChg chg="modSp mod ord">
-        <pc:chgData name="Graf Thomas, SCS-INI-NET-VNC-E2E" userId="487bc3e3-9ce7-4cdd-b7b4-8899ea88d289" providerId="ADAL" clId="{ADEEF08A-D719-4B50-A383-4105EDA2C206}" dt="2026-03-01T12:47:42.066" v="1708" actId="14100"/>
+        <pc:chgData name="Graf Thomas, SCS-INI-NET-VNC-E2E" userId="487bc3e3-9ce7-4cdd-b7b4-8899ea88d289" providerId="ADAL" clId="{ADEEF08A-D719-4B50-A383-4105EDA2C206}" dt="2026-03-14T09:27:50.013" v="1735"/>
         <pc:sldMkLst>
           <pc:docMk/>
           <pc:sldMk cId="3625312977" sldId="2145706298"/>
@@ -720,7 +720,7 @@
         </pc:sldMkLst>
       </pc:sldChg>
       <pc:sldChg chg="modSp mod ord">
-        <pc:chgData name="Graf Thomas, SCS-INI-NET-VNC-E2E" userId="487bc3e3-9ce7-4cdd-b7b4-8899ea88d289" providerId="ADAL" clId="{ADEEF08A-D719-4B50-A383-4105EDA2C206}" dt="2026-03-01T11:54:08.088" v="1670" actId="20577"/>
+        <pc:chgData name="Graf Thomas, SCS-INI-NET-VNC-E2E" userId="487bc3e3-9ce7-4cdd-b7b4-8899ea88d289" providerId="ADAL" clId="{ADEEF08A-D719-4B50-A383-4105EDA2C206}" dt="2026-03-14T09:26:34.469" v="1733" actId="20577"/>
         <pc:sldMkLst>
           <pc:docMk/>
           <pc:sldMk cId="2204044421" sldId="2145706304"/>
@@ -733,9 +733,17 @@
             <ac:spMk id="2" creationId="{01296293-090C-9776-9593-882BE2834B00}"/>
           </ac:spMkLst>
         </pc:spChg>
+        <pc:spChg chg="mod">
+          <ac:chgData name="Graf Thomas, SCS-INI-NET-VNC-E2E" userId="487bc3e3-9ce7-4cdd-b7b4-8899ea88d289" providerId="ADAL" clId="{ADEEF08A-D719-4B50-A383-4105EDA2C206}" dt="2026-03-14T09:26:34.469" v="1733" actId="20577"/>
+          <ac:spMkLst>
+            <pc:docMk/>
+            <pc:sldMk cId="2204044421" sldId="2145706304"/>
+            <ac:spMk id="3" creationId="{BF3239C7-8F4E-0634-8F9F-D16A95D3AAE8}"/>
+          </ac:spMkLst>
+        </pc:spChg>
       </pc:sldChg>
       <pc:sldChg chg="modSp mod ord">
-        <pc:chgData name="Graf Thomas, SCS-INI-NET-VNC-E2E" userId="487bc3e3-9ce7-4cdd-b7b4-8899ea88d289" providerId="ADAL" clId="{ADEEF08A-D719-4B50-A383-4105EDA2C206}" dt="2026-03-06T14:10:39.439" v="1720" actId="20577"/>
+        <pc:chgData name="Graf Thomas, SCS-INI-NET-VNC-E2E" userId="487bc3e3-9ce7-4cdd-b7b4-8899ea88d289" providerId="ADAL" clId="{ADEEF08A-D719-4B50-A383-4105EDA2C206}" dt="2026-03-14T09:25:10.047" v="1729" actId="13926"/>
         <pc:sldMkLst>
           <pc:docMk/>
           <pc:sldMk cId="3686017286" sldId="2145706305"/>
@@ -749,7 +757,7 @@
           </ac:spMkLst>
         </pc:spChg>
         <pc:spChg chg="mod">
-          <ac:chgData name="Graf Thomas, SCS-INI-NET-VNC-E2E" userId="487bc3e3-9ce7-4cdd-b7b4-8899ea88d289" providerId="ADAL" clId="{ADEEF08A-D719-4B50-A383-4105EDA2C206}" dt="2026-03-06T14:10:39.439" v="1720" actId="20577"/>
+          <ac:chgData name="Graf Thomas, SCS-INI-NET-VNC-E2E" userId="487bc3e3-9ce7-4cdd-b7b4-8899ea88d289" providerId="ADAL" clId="{ADEEF08A-D719-4B50-A383-4105EDA2C206}" dt="2026-03-14T09:25:10.047" v="1729" actId="13926"/>
           <ac:spMkLst>
             <pc:docMk/>
             <pc:sldMk cId="3686017286" sldId="2145706305"/>
@@ -758,7 +766,7 @@
         </pc:spChg>
       </pc:sldChg>
       <pc:sldChg chg="modSp mod">
-        <pc:chgData name="Graf Thomas, SCS-INI-NET-VNC-E2E" userId="487bc3e3-9ce7-4cdd-b7b4-8899ea88d289" providerId="ADAL" clId="{ADEEF08A-D719-4B50-A383-4105EDA2C206}" dt="2026-03-06T14:10:47.728" v="1722" actId="20577"/>
+        <pc:chgData name="Graf Thomas, SCS-INI-NET-VNC-E2E" userId="487bc3e3-9ce7-4cdd-b7b4-8899ea88d289" providerId="ADAL" clId="{ADEEF08A-D719-4B50-A383-4105EDA2C206}" dt="2026-03-14T09:24:40.762" v="1728" actId="20577"/>
         <pc:sldMkLst>
           <pc:docMk/>
           <pc:sldMk cId="3305081943" sldId="2145706306"/>
@@ -780,7 +788,7 @@
           </ac:spMkLst>
         </pc:spChg>
         <pc:spChg chg="mod">
-          <ac:chgData name="Graf Thomas, SCS-INI-NET-VNC-E2E" userId="487bc3e3-9ce7-4cdd-b7b4-8899ea88d289" providerId="ADAL" clId="{ADEEF08A-D719-4B50-A383-4105EDA2C206}" dt="2026-03-06T14:10:47.728" v="1722" actId="20577"/>
+          <ac:chgData name="Graf Thomas, SCS-INI-NET-VNC-E2E" userId="487bc3e3-9ce7-4cdd-b7b4-8899ea88d289" providerId="ADAL" clId="{ADEEF08A-D719-4B50-A383-4105EDA2C206}" dt="2026-03-14T09:24:40.762" v="1728" actId="20577"/>
           <ac:spMkLst>
             <pc:docMk/>
             <pc:sldMk cId="3305081943" sldId="2145706306"/>
@@ -875,7 +883,7 @@
           <a:p>
             <a:fld id="{E5E705E9-673F-4AC4-B29E-A7B26F3B8523}" type="datetimeFigureOut">
               <a:rPr lang="de-CH" smtClean="0"/>
-              <a:t>06.03.2026</a:t>
+              <a:t>14.03.2026</a:t>
             </a:fld>
             <a:endParaRPr lang="de-CH"/>
           </a:p>
@@ -1381,7 +1389,7 @@
           <a:p>
             <a:fld id="{9E9B238C-2335-4007-98C9-471C02CC43B6}" type="datetimeFigureOut">
               <a:rPr lang="de-CH" smtClean="0"/>
-              <a:t>06.03.2026</a:t>
+              <a:t>14.03.2026</a:t>
             </a:fld>
             <a:endParaRPr lang="de-CH"/>
           </a:p>
@@ -1581,7 +1589,7 @@
           <a:p>
             <a:fld id="{9E9B238C-2335-4007-98C9-471C02CC43B6}" type="datetimeFigureOut">
               <a:rPr lang="de-CH" smtClean="0"/>
-              <a:t>06.03.2026</a:t>
+              <a:t>14.03.2026</a:t>
             </a:fld>
             <a:endParaRPr lang="de-CH"/>
           </a:p>
@@ -1791,7 +1799,7 @@
           <a:p>
             <a:fld id="{9E9B238C-2335-4007-98C9-471C02CC43B6}" type="datetimeFigureOut">
               <a:rPr lang="de-CH" smtClean="0"/>
-              <a:t>06.03.2026</a:t>
+              <a:t>14.03.2026</a:t>
             </a:fld>
             <a:endParaRPr lang="de-CH"/>
           </a:p>
@@ -3233,7 +3241,7 @@
           <a:p>
             <a:fld id="{9E9B238C-2335-4007-98C9-471C02CC43B6}" type="datetimeFigureOut">
               <a:rPr lang="de-CH" smtClean="0"/>
-              <a:t>06.03.2026</a:t>
+              <a:t>14.03.2026</a:t>
             </a:fld>
             <a:endParaRPr lang="de-CH"/>
           </a:p>
@@ -3509,7 +3517,7 @@
           <a:p>
             <a:fld id="{9E9B238C-2335-4007-98C9-471C02CC43B6}" type="datetimeFigureOut">
               <a:rPr lang="de-CH" smtClean="0"/>
-              <a:t>06.03.2026</a:t>
+              <a:t>14.03.2026</a:t>
             </a:fld>
             <a:endParaRPr lang="de-CH"/>
           </a:p>
@@ -3777,7 +3785,7 @@
           <a:p>
             <a:fld id="{9E9B238C-2335-4007-98C9-471C02CC43B6}" type="datetimeFigureOut">
               <a:rPr lang="de-CH" smtClean="0"/>
-              <a:t>06.03.2026</a:t>
+              <a:t>14.03.2026</a:t>
             </a:fld>
             <a:endParaRPr lang="de-CH"/>
           </a:p>
@@ -4192,7 +4200,7 @@
           <a:p>
             <a:fld id="{9E9B238C-2335-4007-98C9-471C02CC43B6}" type="datetimeFigureOut">
               <a:rPr lang="de-CH" smtClean="0"/>
-              <a:t>06.03.2026</a:t>
+              <a:t>14.03.2026</a:t>
             </a:fld>
             <a:endParaRPr lang="de-CH"/>
           </a:p>
@@ -4334,7 +4342,7 @@
           <a:p>
             <a:fld id="{9E9B238C-2335-4007-98C9-471C02CC43B6}" type="datetimeFigureOut">
               <a:rPr lang="de-CH" smtClean="0"/>
-              <a:t>06.03.2026</a:t>
+              <a:t>14.03.2026</a:t>
             </a:fld>
             <a:endParaRPr lang="de-CH"/>
           </a:p>
@@ -4447,7 +4455,7 @@
           <a:p>
             <a:fld id="{9E9B238C-2335-4007-98C9-471C02CC43B6}" type="datetimeFigureOut">
               <a:rPr lang="de-CH" smtClean="0"/>
-              <a:t>06.03.2026</a:t>
+              <a:t>14.03.2026</a:t>
             </a:fld>
             <a:endParaRPr lang="de-CH"/>
           </a:p>
@@ -4760,7 +4768,7 @@
           <a:p>
             <a:fld id="{9E9B238C-2335-4007-98C9-471C02CC43B6}" type="datetimeFigureOut">
               <a:rPr lang="de-CH" smtClean="0"/>
-              <a:t>06.03.2026</a:t>
+              <a:t>14.03.2026</a:t>
             </a:fld>
             <a:endParaRPr lang="de-CH"/>
           </a:p>
@@ -5049,7 +5057,7 @@
           <a:p>
             <a:fld id="{9E9B238C-2335-4007-98C9-471C02CC43B6}" type="datetimeFigureOut">
               <a:rPr lang="de-CH" smtClean="0"/>
-              <a:t>06.03.2026</a:t>
+              <a:t>14.03.2026</a:t>
             </a:fld>
             <a:endParaRPr lang="de-CH"/>
           </a:p>
@@ -5292,7 +5300,7 @@
           <a:p>
             <a:fld id="{9E9B238C-2335-4007-98C9-471C02CC43B6}" type="datetimeFigureOut">
               <a:rPr lang="de-CH" smtClean="0"/>
-              <a:t>06.03.2026</a:t>
+              <a:t>14.03.2026</a:t>
             </a:fld>
             <a:endParaRPr lang="de-CH"/>
           </a:p>
@@ -6122,7 +6130,7 @@
               <a:rPr lang="en-US" sz="1400" dirty="0">
                 <a:latin typeface="+mj-lt"/>
               </a:rPr>
-              <a:t>6. March </a:t>
+              <a:t>14. March </a:t>
             </a:r>
             <a:r>
               <a:rPr lang="en-US" sz="1400" dirty="0">
@@ -6156,355 +6164,6 @@
 </file>
 
 <file path=ppt/slides/slide2.xml><?xml version="1.0" encoding="utf-8"?>
-<p:sld xmlns:a="http://schemas.openxmlformats.org/drawingml/2006/main" xmlns:r="http://schemas.openxmlformats.org/officeDocument/2006/relationships" xmlns:p="http://schemas.openxmlformats.org/presentationml/2006/main">
-  <p:cSld>
-    <p:spTree>
-      <p:nvGrpSpPr>
-        <p:cNvPr id="1" name="">
-          <a:extLst>
-            <a:ext uri="{FF2B5EF4-FFF2-40B4-BE49-F238E27FC236}">
-              <a16:creationId xmlns:a16="http://schemas.microsoft.com/office/drawing/2014/main" id="{F8D76F2D-4A59-3EAC-54AD-8473DAE26610}"/>
-            </a:ext>
-          </a:extLst>
-        </p:cNvPr>
-        <p:cNvGrpSpPr/>
-        <p:nvPr/>
-      </p:nvGrpSpPr>
-      <p:grpSpPr>
-        <a:xfrm>
-          <a:off x="0" y="0"/>
-          <a:ext cx="0" cy="0"/>
-          <a:chOff x="0" y="0"/>
-          <a:chExt cx="0" cy="0"/>
-        </a:xfrm>
-      </p:grpSpPr>
-      <p:sp>
-        <p:nvSpPr>
-          <p:cNvPr id="2" name="Title 1">
-            <a:extLst>
-              <a:ext uri="{FF2B5EF4-FFF2-40B4-BE49-F238E27FC236}">
-                <a16:creationId xmlns:a16="http://schemas.microsoft.com/office/drawing/2014/main" id="{B88E132A-D116-CDE2-7382-6119AE1C937E}"/>
-              </a:ext>
-            </a:extLst>
-          </p:cNvPr>
-          <p:cNvSpPr>
-            <a:spLocks noGrp="1"/>
-          </p:cNvSpPr>
-          <p:nvPr>
-            <p:ph type="title"/>
-          </p:nvPr>
-        </p:nvSpPr>
-        <p:spPr/>
-        <p:txBody>
-          <a:bodyPr>
-            <a:normAutofit/>
-          </a:bodyPr>
-          <a:lstStyle/>
-          <a:p>
-            <a:r>
-              <a:rPr lang="en-US" sz="2800" b="1" dirty="0"/>
-              <a:t>Message Broker Integration</a:t>
-            </a:r>
-            <a:br>
-              <a:rPr lang="en-US" sz="3600" dirty="0"/>
-            </a:br>
-            <a:r>
-              <a:rPr lang="en-US" sz="2700" dirty="0">
-                <a:solidFill>
-                  <a:schemeClr val="bg2">
-                    <a:lumMod val="75000"/>
-                  </a:schemeClr>
-                </a:solidFill>
-              </a:rPr>
-              <a:t>Document Relationships</a:t>
-            </a:r>
-          </a:p>
-        </p:txBody>
-      </p:sp>
-      <p:sp>
-        <p:nvSpPr>
-          <p:cNvPr id="3" name="Content Placeholder 2">
-            <a:extLst>
-              <a:ext uri="{FF2B5EF4-FFF2-40B4-BE49-F238E27FC236}">
-                <a16:creationId xmlns:a16="http://schemas.microsoft.com/office/drawing/2014/main" id="{C1F459B2-AF0B-A44B-E182-6B111FE67A0A}"/>
-              </a:ext>
-            </a:extLst>
-          </p:cNvPr>
-          <p:cNvSpPr>
-            <a:spLocks noGrp="1"/>
-          </p:cNvSpPr>
-          <p:nvPr>
-            <p:ph idx="1"/>
-          </p:nvPr>
-        </p:nvSpPr>
-        <p:spPr>
-          <a:xfrm>
-            <a:off x="838199" y="1690688"/>
-            <a:ext cx="10515600" cy="4486275"/>
-          </a:xfrm>
-        </p:spPr>
-        <p:txBody>
-          <a:bodyPr>
-            <a:noAutofit/>
-          </a:bodyPr>
-          <a:lstStyle/>
-          <a:p>
-            <a:pPr marL="0" indent="0">
-              <a:spcBef>
-                <a:spcPts val="600"/>
-              </a:spcBef>
-              <a:spcAft>
-                <a:spcPts val="1200"/>
-              </a:spcAft>
-              <a:buNone/>
-            </a:pPr>
-            <a:r>
-              <a:rPr lang="en-US" sz="2100" dirty="0"/>
-              <a:t>These are the documents related to the Message Broker integration:</a:t>
-            </a:r>
-          </a:p>
-          <a:p>
-            <a:pPr>
-              <a:spcBef>
-                <a:spcPts val="600"/>
-              </a:spcBef>
-            </a:pPr>
-            <a:r>
-              <a:rPr lang="en-US" sz="2100" dirty="0">
-                <a:hlinkClick r:id="rId2"/>
-              </a:rPr>
-              <a:t>draft-</a:t>
-            </a:r>
-            <a:r>
-              <a:rPr lang="en-US" sz="2100" dirty="0" err="1">
-                <a:hlinkClick r:id="rId2"/>
-              </a:rPr>
-              <a:t>ietf</a:t>
-            </a:r>
-            <a:r>
-              <a:rPr lang="en-US" sz="2100" dirty="0">
-                <a:hlinkClick r:id="rId2"/>
-              </a:rPr>
-              <a:t>-</a:t>
-            </a:r>
-            <a:r>
-              <a:rPr lang="en-US" sz="2100" dirty="0" err="1">
-                <a:hlinkClick r:id="rId2"/>
-              </a:rPr>
-              <a:t>nmop</a:t>
-            </a:r>
-            <a:r>
-              <a:rPr lang="en-US" sz="2100" dirty="0">
-                <a:hlinkClick r:id="rId2"/>
-              </a:rPr>
-              <a:t>-yang-message-broker-integration</a:t>
-            </a:r>
-            <a:r>
-              <a:rPr lang="en-US" sz="2100" dirty="0"/>
-              <a:t> defines the YANG-Push to message broker integration architecture.</a:t>
-            </a:r>
-          </a:p>
-          <a:p>
-            <a:pPr>
-              <a:spcBef>
-                <a:spcPts val="0"/>
-              </a:spcBef>
-            </a:pPr>
-            <a:r>
-              <a:rPr lang="en-US" sz="2100" dirty="0">
-                <a:hlinkClick r:id="rId3"/>
-              </a:rPr>
-              <a:t>draft-</a:t>
-            </a:r>
-            <a:r>
-              <a:rPr lang="en-US" sz="2100" dirty="0" err="1">
-                <a:hlinkClick r:id="rId3"/>
-              </a:rPr>
-              <a:t>ietf</a:t>
-            </a:r>
-            <a:r>
-              <a:rPr lang="en-US" sz="2100" dirty="0">
-                <a:hlinkClick r:id="rId3"/>
-              </a:rPr>
-              <a:t>-</a:t>
-            </a:r>
-            <a:r>
-              <a:rPr lang="en-US" sz="2100" dirty="0" err="1">
-                <a:hlinkClick r:id="rId3"/>
-              </a:rPr>
-              <a:t>nmop</a:t>
-            </a:r>
-            <a:r>
-              <a:rPr lang="en-US" sz="2100" dirty="0">
-                <a:hlinkClick r:id="rId3"/>
-              </a:rPr>
-              <a:t>-message-broker-telemetry-message</a:t>
-            </a:r>
-            <a:r>
-              <a:rPr lang="en-US" sz="2100" dirty="0"/>
-              <a:t> defines the message schema being used between YANG data producer and consumer.</a:t>
-            </a:r>
-          </a:p>
-          <a:p>
-            <a:pPr>
-              <a:spcBef>
-                <a:spcPts val="0"/>
-              </a:spcBef>
-            </a:pPr>
-            <a:r>
-              <a:rPr lang="en-US" sz="2100" b="1" dirty="0">
-                <a:solidFill>
-                  <a:srgbClr val="FF0000"/>
-                </a:solidFill>
-              </a:rPr>
-              <a:t>Adopted: </a:t>
-            </a:r>
-            <a:r>
-              <a:rPr lang="en-US" sz="2100" dirty="0">
-                <a:hlinkClick r:id="rId4"/>
-              </a:rPr>
-              <a:t>draft-</a:t>
-            </a:r>
-            <a:r>
-              <a:rPr lang="en-US" sz="2100" dirty="0" err="1">
-                <a:hlinkClick r:id="rId4"/>
-              </a:rPr>
-              <a:t>ietf</a:t>
-            </a:r>
-            <a:r>
-              <a:rPr lang="en-US" sz="2100" dirty="0">
-                <a:hlinkClick r:id="rId4"/>
-              </a:rPr>
-              <a:t>-</a:t>
-            </a:r>
-            <a:r>
-              <a:rPr lang="en-US" sz="2100" dirty="0" err="1">
-                <a:hlinkClick r:id="rId4"/>
-              </a:rPr>
-              <a:t>nmop</a:t>
-            </a:r>
-            <a:r>
-              <a:rPr lang="en-US" sz="2100" dirty="0">
-                <a:hlinkClick r:id="rId4"/>
-              </a:rPr>
-              <a:t>-yang-message-broker-message-key</a:t>
-            </a:r>
-            <a:r>
-              <a:rPr lang="en-US" sz="2100" dirty="0"/>
-              <a:t> defines how YANG-Push metrics can be indexed and addressed efficiently and therefore reduce the number of consumed messages and reduce the number of stored metrics with topic compaction.</a:t>
-            </a:r>
-          </a:p>
-          <a:p>
-            <a:pPr>
-              <a:spcBef>
-                <a:spcPts val="0"/>
-              </a:spcBef>
-            </a:pPr>
-            <a:r>
-              <a:rPr lang="en-US" sz="2100" b="1" dirty="0">
-                <a:solidFill>
-                  <a:srgbClr val="FF0000"/>
-                </a:solidFill>
-              </a:rPr>
-              <a:t>New: </a:t>
-            </a:r>
-            <a:r>
-              <a:rPr lang="en-US" sz="2100" dirty="0">
-                <a:hlinkClick r:id="rId5"/>
-              </a:rPr>
-              <a:t>draft-</a:t>
-            </a:r>
-            <a:r>
-              <a:rPr lang="en-US" sz="2100" dirty="0" err="1">
-                <a:hlinkClick r:id="rId5"/>
-              </a:rPr>
-              <a:t>netana</a:t>
-            </a:r>
-            <a:r>
-              <a:rPr lang="en-US" sz="2100" dirty="0">
-                <a:hlinkClick r:id="rId5"/>
-              </a:rPr>
-              <a:t>-</a:t>
-            </a:r>
-            <a:r>
-              <a:rPr lang="en-US" sz="2100" dirty="0" err="1">
-                <a:hlinkClick r:id="rId5"/>
-              </a:rPr>
-              <a:t>nmop</a:t>
-            </a:r>
-            <a:r>
-              <a:rPr lang="en-US" sz="2100" dirty="0">
-                <a:hlinkClick r:id="rId5"/>
-              </a:rPr>
-              <a:t>-message-broker-bmp-telemetry-msg</a:t>
-            </a:r>
-            <a:r>
-              <a:rPr lang="en-US" sz="2100" dirty="0"/>
-              <a:t> defines the message schema extensions for BMP transformation and how message keys and topic names are derived.</a:t>
-            </a:r>
-          </a:p>
-          <a:p>
-            <a:pPr marL="0" indent="0">
-              <a:spcBef>
-                <a:spcPts val="1200"/>
-              </a:spcBef>
-              <a:buNone/>
-            </a:pPr>
-            <a:r>
-              <a:rPr lang="en-US" sz="2100" dirty="0"/>
-              <a:t>At the IETF 124 NMOP session we introduced the working group to the differences between topics, partitions, subjects, segments, messages and message keys and how the apply to topic naming and compaction and how YANG-Push capabilities and YANG catalogs facilitate YANG metrics subscription in the network and data mesh.</a:t>
-            </a:r>
-          </a:p>
-        </p:txBody>
-      </p:sp>
-      <p:sp>
-        <p:nvSpPr>
-          <p:cNvPr id="6" name="Slide Number Placeholder 1">
-            <a:extLst>
-              <a:ext uri="{FF2B5EF4-FFF2-40B4-BE49-F238E27FC236}">
-                <a16:creationId xmlns:a16="http://schemas.microsoft.com/office/drawing/2014/main" id="{26AA2D5F-D741-6D6F-EF24-BE22738048DF}"/>
-              </a:ext>
-            </a:extLst>
-          </p:cNvPr>
-          <p:cNvSpPr>
-            <a:spLocks noGrp="1"/>
-          </p:cNvSpPr>
-          <p:nvPr>
-            <p:ph type="sldNum" sz="quarter" idx="12"/>
-          </p:nvPr>
-        </p:nvSpPr>
-        <p:spPr>
-          <a:xfrm>
-            <a:off x="11587892" y="6361637"/>
-            <a:ext cx="414251" cy="365125"/>
-          </a:xfrm>
-        </p:spPr>
-        <p:txBody>
-          <a:bodyPr/>
-          <a:lstStyle/>
-          <a:p>
-            <a:fld id="{FC4AC485-25DE-431E-B345-9C0A15BB7F8A}" type="slidenum">
-              <a:rPr lang="en-US" sz="1400" smtClean="0"/>
-              <a:t>2</a:t>
-            </a:fld>
-            <a:endParaRPr lang="en-US" sz="1400" dirty="0"/>
-          </a:p>
-        </p:txBody>
-      </p:sp>
-    </p:spTree>
-    <p:extLst>
-      <p:ext uri="{BB962C8B-B14F-4D97-AF65-F5344CB8AC3E}">
-        <p14:creationId xmlns:p14="http://schemas.microsoft.com/office/powerpoint/2010/main" val="3686017286"/>
-      </p:ext>
-    </p:extLst>
-  </p:cSld>
-  <p:clrMapOvr>
-    <a:masterClrMapping/>
-  </p:clrMapOvr>
-</p:sld>
-</file>
-
-<file path=ppt/slides/slide3.xml><?xml version="1.0" encoding="utf-8"?>
 <p:sld xmlns:a="http://schemas.openxmlformats.org/drawingml/2006/main" xmlns:r="http://schemas.openxmlformats.org/officeDocument/2006/relationships" xmlns:p="http://schemas.openxmlformats.org/presentationml/2006/main">
   <p:cSld>
     <p:spTree>
@@ -6555,7 +6214,7 @@
           <a:p>
             <a:fld id="{FC4AC485-25DE-431E-B345-9C0A15BB7F8A}" type="slidenum">
               <a:rPr lang="de-CH" sz="1400" smtClean="0"/>
-              <a:t>3</a:t>
+              <a:t>2</a:t>
             </a:fld>
             <a:endParaRPr lang="de-CH" sz="1400" dirty="0"/>
           </a:p>
@@ -6966,6 +6625,377 @@
 </p:sld>
 </file>
 
+<file path=ppt/slides/slide3.xml><?xml version="1.0" encoding="utf-8"?>
+<p:sld xmlns:a="http://schemas.openxmlformats.org/drawingml/2006/main" xmlns:r="http://schemas.openxmlformats.org/officeDocument/2006/relationships" xmlns:p="http://schemas.openxmlformats.org/presentationml/2006/main">
+  <p:cSld>
+    <p:spTree>
+      <p:nvGrpSpPr>
+        <p:cNvPr id="1" name="">
+          <a:extLst>
+            <a:ext uri="{FF2B5EF4-FFF2-40B4-BE49-F238E27FC236}">
+              <a16:creationId xmlns:a16="http://schemas.microsoft.com/office/drawing/2014/main" id="{F8D76F2D-4A59-3EAC-54AD-8473DAE26610}"/>
+            </a:ext>
+          </a:extLst>
+        </p:cNvPr>
+        <p:cNvGrpSpPr/>
+        <p:nvPr/>
+      </p:nvGrpSpPr>
+      <p:grpSpPr>
+        <a:xfrm>
+          <a:off x="0" y="0"/>
+          <a:ext cx="0" cy="0"/>
+          <a:chOff x="0" y="0"/>
+          <a:chExt cx="0" cy="0"/>
+        </a:xfrm>
+      </p:grpSpPr>
+      <p:sp>
+        <p:nvSpPr>
+          <p:cNvPr id="2" name="Title 1">
+            <a:extLst>
+              <a:ext uri="{FF2B5EF4-FFF2-40B4-BE49-F238E27FC236}">
+                <a16:creationId xmlns:a16="http://schemas.microsoft.com/office/drawing/2014/main" id="{B88E132A-D116-CDE2-7382-6119AE1C937E}"/>
+              </a:ext>
+            </a:extLst>
+          </p:cNvPr>
+          <p:cNvSpPr>
+            <a:spLocks noGrp="1"/>
+          </p:cNvSpPr>
+          <p:nvPr>
+            <p:ph type="title"/>
+          </p:nvPr>
+        </p:nvSpPr>
+        <p:spPr/>
+        <p:txBody>
+          <a:bodyPr>
+            <a:normAutofit/>
+          </a:bodyPr>
+          <a:lstStyle/>
+          <a:p>
+            <a:r>
+              <a:rPr lang="en-US" sz="2800" b="1" dirty="0"/>
+              <a:t>Message Broker Integration</a:t>
+            </a:r>
+            <a:br>
+              <a:rPr lang="en-US" sz="3600" dirty="0"/>
+            </a:br>
+            <a:r>
+              <a:rPr lang="en-US" sz="2700" dirty="0">
+                <a:solidFill>
+                  <a:schemeClr val="bg2">
+                    <a:lumMod val="75000"/>
+                  </a:schemeClr>
+                </a:solidFill>
+              </a:rPr>
+              <a:t>Document Relationships</a:t>
+            </a:r>
+          </a:p>
+        </p:txBody>
+      </p:sp>
+      <p:sp>
+        <p:nvSpPr>
+          <p:cNvPr id="3" name="Content Placeholder 2">
+            <a:extLst>
+              <a:ext uri="{FF2B5EF4-FFF2-40B4-BE49-F238E27FC236}">
+                <a16:creationId xmlns:a16="http://schemas.microsoft.com/office/drawing/2014/main" id="{C1F459B2-AF0B-A44B-E182-6B111FE67A0A}"/>
+              </a:ext>
+            </a:extLst>
+          </p:cNvPr>
+          <p:cNvSpPr>
+            <a:spLocks noGrp="1"/>
+          </p:cNvSpPr>
+          <p:nvPr>
+            <p:ph idx="1"/>
+          </p:nvPr>
+        </p:nvSpPr>
+        <p:spPr>
+          <a:xfrm>
+            <a:off x="838199" y="1690688"/>
+            <a:ext cx="10515600" cy="4486275"/>
+          </a:xfrm>
+        </p:spPr>
+        <p:txBody>
+          <a:bodyPr>
+            <a:noAutofit/>
+          </a:bodyPr>
+          <a:lstStyle/>
+          <a:p>
+            <a:pPr marL="0" indent="0">
+              <a:spcBef>
+                <a:spcPts val="600"/>
+              </a:spcBef>
+              <a:spcAft>
+                <a:spcPts val="1200"/>
+              </a:spcAft>
+              <a:buNone/>
+            </a:pPr>
+            <a:r>
+              <a:rPr lang="en-US" sz="2100" dirty="0"/>
+              <a:t>These are the documents related to the Message Broker integration:</a:t>
+            </a:r>
+          </a:p>
+          <a:p>
+            <a:pPr>
+              <a:spcBef>
+                <a:spcPts val="600"/>
+              </a:spcBef>
+            </a:pPr>
+            <a:r>
+              <a:rPr lang="en-US" sz="2100" dirty="0">
+                <a:hlinkClick r:id="rId2"/>
+              </a:rPr>
+              <a:t>draft-</a:t>
+            </a:r>
+            <a:r>
+              <a:rPr lang="en-US" sz="2100" dirty="0" err="1">
+                <a:hlinkClick r:id="rId2"/>
+              </a:rPr>
+              <a:t>ietf</a:t>
+            </a:r>
+            <a:r>
+              <a:rPr lang="en-US" sz="2100" dirty="0">
+                <a:hlinkClick r:id="rId2"/>
+              </a:rPr>
+              <a:t>-</a:t>
+            </a:r>
+            <a:r>
+              <a:rPr lang="en-US" sz="2100" dirty="0" err="1">
+                <a:hlinkClick r:id="rId2"/>
+              </a:rPr>
+              <a:t>nmop</a:t>
+            </a:r>
+            <a:r>
+              <a:rPr lang="en-US" sz="2100" dirty="0">
+                <a:hlinkClick r:id="rId2"/>
+              </a:rPr>
+              <a:t>-yang-message-broker-integration</a:t>
+            </a:r>
+            <a:r>
+              <a:rPr lang="en-US" sz="2100" dirty="0"/>
+              <a:t> defines the YANG-Push to message broker integration architecture.</a:t>
+            </a:r>
+          </a:p>
+          <a:p>
+            <a:pPr>
+              <a:spcBef>
+                <a:spcPts val="0"/>
+              </a:spcBef>
+            </a:pPr>
+            <a:r>
+              <a:rPr lang="en-US" sz="2100" dirty="0">
+                <a:hlinkClick r:id="rId3"/>
+              </a:rPr>
+              <a:t>draft-</a:t>
+            </a:r>
+            <a:r>
+              <a:rPr lang="en-US" sz="2100" dirty="0" err="1">
+                <a:hlinkClick r:id="rId3"/>
+              </a:rPr>
+              <a:t>ietf</a:t>
+            </a:r>
+            <a:r>
+              <a:rPr lang="en-US" sz="2100" dirty="0">
+                <a:hlinkClick r:id="rId3"/>
+              </a:rPr>
+              <a:t>-</a:t>
+            </a:r>
+            <a:r>
+              <a:rPr lang="en-US" sz="2100" dirty="0" err="1">
+                <a:hlinkClick r:id="rId3"/>
+              </a:rPr>
+              <a:t>nmop</a:t>
+            </a:r>
+            <a:r>
+              <a:rPr lang="en-US" sz="2100" dirty="0">
+                <a:hlinkClick r:id="rId3"/>
+              </a:rPr>
+              <a:t>-message-broker-telemetry-message</a:t>
+            </a:r>
+            <a:r>
+              <a:rPr lang="en-US" sz="2100" dirty="0"/>
+              <a:t> defines the message schema being used between YANG data producer and consumer.</a:t>
+            </a:r>
+          </a:p>
+          <a:p>
+            <a:pPr>
+              <a:spcBef>
+                <a:spcPts val="0"/>
+              </a:spcBef>
+            </a:pPr>
+            <a:r>
+              <a:rPr lang="en-US" sz="2100" b="1" dirty="0">
+                <a:solidFill>
+                  <a:srgbClr val="FF0000"/>
+                </a:solidFill>
+                <a:highlight>
+                  <a:srgbClr val="FFFF00"/>
+                </a:highlight>
+              </a:rPr>
+              <a:t>Adopted: </a:t>
+            </a:r>
+            <a:r>
+              <a:rPr lang="en-US" sz="2100" dirty="0">
+                <a:highlight>
+                  <a:srgbClr val="FFFF00"/>
+                </a:highlight>
+                <a:hlinkClick r:id="rId4"/>
+              </a:rPr>
+              <a:t>draft-</a:t>
+            </a:r>
+            <a:r>
+              <a:rPr lang="en-US" sz="2100" dirty="0" err="1">
+                <a:highlight>
+                  <a:srgbClr val="FFFF00"/>
+                </a:highlight>
+                <a:hlinkClick r:id="rId4"/>
+              </a:rPr>
+              <a:t>ietf</a:t>
+            </a:r>
+            <a:r>
+              <a:rPr lang="en-US" sz="2100" dirty="0">
+                <a:highlight>
+                  <a:srgbClr val="FFFF00"/>
+                </a:highlight>
+                <a:hlinkClick r:id="rId4"/>
+              </a:rPr>
+              <a:t>-</a:t>
+            </a:r>
+            <a:r>
+              <a:rPr lang="en-US" sz="2100" dirty="0" err="1">
+                <a:highlight>
+                  <a:srgbClr val="FFFF00"/>
+                </a:highlight>
+                <a:hlinkClick r:id="rId4"/>
+              </a:rPr>
+              <a:t>nmop</a:t>
+            </a:r>
+            <a:r>
+              <a:rPr lang="en-US" sz="2100" dirty="0">
+                <a:highlight>
+                  <a:srgbClr val="FFFF00"/>
+                </a:highlight>
+                <a:hlinkClick r:id="rId4"/>
+              </a:rPr>
+              <a:t>-yang-message-broker-message-key</a:t>
+            </a:r>
+            <a:r>
+              <a:rPr lang="en-US" sz="2100" dirty="0">
+                <a:highlight>
+                  <a:srgbClr val="FFFF00"/>
+                </a:highlight>
+              </a:rPr>
+              <a:t> defines how YANG-Push metrics can be indexed and addressed efficiently and therefore reduce the number of consumed messages and reduce the number of stored metrics with topic compaction.</a:t>
+            </a:r>
+          </a:p>
+          <a:p>
+            <a:pPr>
+              <a:spcBef>
+                <a:spcPts val="0"/>
+              </a:spcBef>
+            </a:pPr>
+            <a:r>
+              <a:rPr lang="en-US" sz="2100" b="1" dirty="0">
+                <a:solidFill>
+                  <a:srgbClr val="FF0000"/>
+                </a:solidFill>
+              </a:rPr>
+              <a:t>New: </a:t>
+            </a:r>
+            <a:r>
+              <a:rPr lang="en-US" sz="2100" dirty="0">
+                <a:hlinkClick r:id="rId5"/>
+              </a:rPr>
+              <a:t>draft-</a:t>
+            </a:r>
+            <a:r>
+              <a:rPr lang="en-US" sz="2100" dirty="0" err="1">
+                <a:hlinkClick r:id="rId5"/>
+              </a:rPr>
+              <a:t>netana</a:t>
+            </a:r>
+            <a:r>
+              <a:rPr lang="en-US" sz="2100" dirty="0">
+                <a:hlinkClick r:id="rId5"/>
+              </a:rPr>
+              <a:t>-</a:t>
+            </a:r>
+            <a:r>
+              <a:rPr lang="en-US" sz="2100" dirty="0" err="1">
+                <a:hlinkClick r:id="rId5"/>
+              </a:rPr>
+              <a:t>nmop</a:t>
+            </a:r>
+            <a:r>
+              <a:rPr lang="en-US" sz="2100" dirty="0">
+                <a:hlinkClick r:id="rId5"/>
+              </a:rPr>
+              <a:t>-message-broker-bmp-telemetry-msg</a:t>
+            </a:r>
+            <a:r>
+              <a:rPr lang="en-US" sz="2100" dirty="0"/>
+              <a:t> defines the message schema extensions for BMP transformation and how message keys and topic names are derived.</a:t>
+            </a:r>
+          </a:p>
+          <a:p>
+            <a:pPr marL="0" indent="0">
+              <a:spcBef>
+                <a:spcPts val="1200"/>
+              </a:spcBef>
+              <a:buNone/>
+            </a:pPr>
+            <a:r>
+              <a:rPr lang="en-US" sz="2100" dirty="0"/>
+              <a:t>At the IETF 124 NMOP session we introduced the working group to the differences between topics, partitions, subjects, segments, messages and message keys and how the apply to topic naming and compaction and how YANG-Push capabilities and YANG catalogs facilitate YANG metrics subscription in the network and data mesh.</a:t>
+            </a:r>
+          </a:p>
+        </p:txBody>
+      </p:sp>
+      <p:sp>
+        <p:nvSpPr>
+          <p:cNvPr id="6" name="Slide Number Placeholder 1">
+            <a:extLst>
+              <a:ext uri="{FF2B5EF4-FFF2-40B4-BE49-F238E27FC236}">
+                <a16:creationId xmlns:a16="http://schemas.microsoft.com/office/drawing/2014/main" id="{26AA2D5F-D741-6D6F-EF24-BE22738048DF}"/>
+              </a:ext>
+            </a:extLst>
+          </p:cNvPr>
+          <p:cNvSpPr>
+            <a:spLocks noGrp="1"/>
+          </p:cNvSpPr>
+          <p:nvPr>
+            <p:ph type="sldNum" sz="quarter" idx="12"/>
+          </p:nvPr>
+        </p:nvSpPr>
+        <p:spPr>
+          <a:xfrm>
+            <a:off x="11587892" y="6361637"/>
+            <a:ext cx="414251" cy="365125"/>
+          </a:xfrm>
+        </p:spPr>
+        <p:txBody>
+          <a:bodyPr/>
+          <a:lstStyle/>
+          <a:p>
+            <a:fld id="{FC4AC485-25DE-431E-B345-9C0A15BB7F8A}" type="slidenum">
+              <a:rPr lang="en-US" sz="1400" smtClean="0"/>
+              <a:t>3</a:t>
+            </a:fld>
+            <a:endParaRPr lang="en-US" sz="1400" dirty="0"/>
+          </a:p>
+        </p:txBody>
+      </p:sp>
+    </p:spTree>
+    <p:extLst>
+      <p:ext uri="{BB962C8B-B14F-4D97-AF65-F5344CB8AC3E}">
+        <p14:creationId xmlns:p14="http://schemas.microsoft.com/office/powerpoint/2010/main" val="3686017286"/>
+      </p:ext>
+    </p:extLst>
+  </p:cSld>
+  <p:clrMapOvr>
+    <a:masterClrMapping/>
+  </p:clrMapOvr>
+</p:sld>
+</file>
+
 <file path=ppt/slides/slide4.xml><?xml version="1.0" encoding="utf-8"?>
 <p:sld xmlns:a="http://schemas.openxmlformats.org/drawingml/2006/main" xmlns:r="http://schemas.openxmlformats.org/officeDocument/2006/relationships" xmlns:p="http://schemas.openxmlformats.org/presentationml/2006/main">
   <p:cSld>
@@ -7169,9 +7199,19 @@
               </a:rPr>
               <a:t>A network management or network anomaly detection system </a:t>
             </a:r>
+          </a:p>
+          <a:p>
+            <a:pPr>
+              <a:spcBef>
+                <a:spcPts val="600"/>
+              </a:spcBef>
+              <a:spcAft>
+                <a:spcPts val="600"/>
+              </a:spcAft>
+            </a:pPr>
             <a:r>
               <a:rPr lang="en-US" sz="2100" dirty="0"/>
-              <a:t>obtains the current YANG management plane state metrics from project.enviroment.states.yang.* for building a network inventory model and its state See: </a:t>
+              <a:t>Obtains the current YANG management plane state metrics from project.enviroment.states.yang.* for building a network inventory model and its state See: </a:t>
             </a:r>
             <a:r>
               <a:rPr lang="en-US" sz="2100" dirty="0">
@@ -7217,7 +7257,21 @@
             </a:r>
             <a:r>
               <a:rPr lang="en-US" sz="2100" dirty="0"/>
-              <a:t>. From project.enviroment.statistis.yang.* it obtains statistics and maps them to the previously obtained network inventory model. </a:t>
+              <a:t>. </a:t>
+            </a:r>
+          </a:p>
+          <a:p>
+            <a:pPr>
+              <a:spcBef>
+                <a:spcPts val="600"/>
+              </a:spcBef>
+              <a:spcAft>
+                <a:spcPts val="600"/>
+              </a:spcAft>
+            </a:pPr>
+            <a:r>
+              <a:rPr lang="en-US" sz="2100" dirty="0"/>
+              <a:t>From project.enviroment.statistis.yang.* it obtains statistics and maps them to the previously obtained network inventory model. </a:t>
             </a:r>
           </a:p>
           <a:p>
@@ -7816,12 +7870,8 @@
               <a:buNone/>
             </a:pPr>
             <a:r>
-              <a:rPr lang="en-US" sz="1400"/>
-              <a:t>6. </a:t>
-            </a:r>
-            <a:r>
               <a:rPr lang="en-US" sz="1400" dirty="0"/>
-              <a:t>March 2026</a:t>
+              <a:t>14. March 2026</a:t>
             </a:r>
           </a:p>
           <a:p>

</xml_diff>